<commit_message>
Update Customer Tone Annotation Guidelines.md: Refined instructions for labeling customer tones, emphasizing the importance of considering all messages in a conversation and clarifying the order of precedence for tone classification. Adjusted examples to better illustrate the labeling process.
</commit_message>
<xml_diff>
--- a/docs/Phase 1 PPT.pptx
+++ b/docs/Phase 1 PPT.pptx
@@ -1131,7 +1131,43 @@
           <a:p>
             <a:r>
               <a:rPr lang="en-US" dirty="0"/>
-              <a:t>Four reasons: urgency, agent performance, retention and public reputation, and system problems. Mention that tone also depends on context (sarcasm), so human judgment is needed.</a:t>
+              <a:t>Companies get thousands of support messages a day. Tone tells us how the customer is reacting to the help they get.</a:t>
+            </a:r>
+          </a:p>
+          <a:p>
+            <a:r>
+              <a:rPr lang="en-US" dirty="0"/>
+              <a:t>Spot customers who need attention: frustrated or escalating customers can be flagged so a person looks at them sooner. Tone is one signal, next to what the customer actually needs.</a:t>
+            </a:r>
+          </a:p>
+          <a:p>
+            <a:r>
+              <a:rPr lang="en-US" dirty="0"/>
+              <a:t>Help write better replies: an upset customer should not get a cheerful script. Tone helps pick the right words, or decide to bring in a human.</a:t>
+            </a:r>
+          </a:p>
+          <a:p>
+            <a:r>
+              <a:rPr lang="en-US" dirty="0"/>
+              <a:t>Find repeated problems: if many people are upset about refunds in the same week, that points to something worth looking into.</a:t>
+            </a:r>
+          </a:p>
+          <a:p>
+            <a:r>
+              <a:rPr lang="en-US" dirty="0"/>
+              <a:t>New labels for a hard problem: the 2.8 million tweets have no tone labels. Our annotators, you, create them.</a:t>
+            </a:r>
+          </a:p>
+          <a:p>
+            <a:r>
+              <a:rPr lang="en-US" dirty="0"/>
+              <a:t>And it is not easy: “Thanks a lot” after a useless reply is sarcasm, not praise. That is why you read the whole conversation.</a:t>
+            </a:r>
+          </a:p>
+          <a:p>
+            <a:r>
+              <a:rPr lang="en-US" dirty="0"/>
+              <a:t>Takeaway: reading tone correctly helps a company respond to the right customer, in the right way.</a:t>
             </a:r>
           </a:p>
         </p:txBody>
@@ -1218,7 +1254,7 @@
           <a:p>
             <a:r>
               <a:rPr lang="en-US" dirty="0"/>
-              <a:t>Five labels from calm and positive to angry and demanding. The label is the customer's tone at the end of the conversation. Next five slides: one real example per label.</a:t>
+              <a:t>Five labels from calm and positive to angry and demanding. The label is the customer's overall tone across the whole conversation; the last message does not take priority. If tones mix, use the order shown on the slide. Next five slides: one real example per label.</a:t>
             </a:r>
           </a:p>
         </p:txBody>
@@ -1305,7 +1341,7 @@
           <a:p>
             <a:r>
               <a:rPr lang="en-US" dirty="0"/>
-              <a:t>Click once to show the whole conversation, then once more to show the guide panel. 1. Appreciative or positive: The customer asks for nothing and volunteers enthusiasm, then closes with "Awesome thanks". Everything points to satisfaction.</a:t>
+              <a:t>Click once to show the whole conversation, then once more to show the guide panel. 1. Appreciative or positive: The customer expresses enthusiasm in both messages, praising the movie and saying “Awesome thanks”. They ask for nothing, so the exchange supports an Appreciative label.</a:t>
             </a:r>
           </a:p>
         </p:txBody>
@@ -3301,7 +3337,7 @@
                 <a:ea typeface="Calibri" pitchFamily="34" charset="-122"/>
                 <a:cs typeface="Calibri" pitchFamily="34" charset="-120"/>
               </a:rPr>
-              <a:t>Label the tone the customer ends on.</a:t>
+              <a:t>Label the customer's tone across the whole conversation.</a:t>
             </a:r>
             <a:endParaRPr lang="en-US" sz="1500" dirty="0"/>
           </a:p>
@@ -3599,7 +3635,7 @@
                 <a:ea typeface="Calibri" pitchFamily="34" charset="-122"/>
                 <a:cs typeface="Calibri" pitchFamily="34" charset="-120"/>
               </a:rPr>
-              <a:t>Potato runs locally. 6 annotators, 2 batches of 100 conversations each.</a:t>
+              <a:t>6 annotators use Potato locally. Each receives 100 required items and a second, optional batch of 100.</a:t>
             </a:r>
             <a:endParaRPr lang="en-US" sz="1500" dirty="0"/>
           </a:p>
@@ -3736,7 +3772,7 @@
                           <a:ea typeface="Calibri" pitchFamily="34" charset="-122"/>
                           <a:cs typeface="Calibri" pitchFamily="34" charset="-120"/>
                         </a:rPr>
-                        <a:t>Per batch</a:t>
+                        <a:t>Items each</a:t>
                       </a:r>
                       <a:endParaRPr lang="en-US" sz="1400" dirty="0">
                         <a:latin typeface="Calibri" charset="0"/>
@@ -4742,7 +4778,8 @@
                 <a:ea typeface="Calibri" pitchFamily="34" charset="-122"/>
                 <a:cs typeface="Calibri" pitchFamily="34" charset="-120"/>
               </a:rPr>
-              <a:t>Shared sets give agreement and majority-vote labels. Unique items give coverage: about 450 different conversations per batch round.</a:t>
+              <a:t>Per annotator, per batch: 20 + 10 + 5 + 65 = 100 items.
+Distinct conversations: 20 + 30 + 10 + 390 = 450 per round. Up to 900 across both rounds.</a:t>
             </a:r>
             <a:endParaRPr lang="en-US" sz="1500" dirty="0"/>
           </a:p>
@@ -5199,7 +5236,7 @@
       </p:sp>
       <p:pic>
         <p:nvPicPr>
-          <p:cNvPr id="5" name="Image 0" descr="Spot urgency early"/>
+          <p:cNvPr id="5" name="Image 0" descr="Spot customers who need attention"/>
           <p:cNvPicPr>
             <a:picLocks noChangeAspect="1"/>
           </p:cNvPicPr>
@@ -5254,7 +5291,7 @@
                 <a:ea typeface="Cambria" pitchFamily="34" charset="-122"/>
                 <a:cs typeface="Cambria" pitchFamily="34" charset="-120"/>
               </a:rPr>
-              <a:t>Spot urgency early</a:t>
+              <a:t>Spot customers who need attention</a:t>
             </a:r>
             <a:endParaRPr lang="en-US" sz="2000" dirty="0"/>
           </a:p>
@@ -5293,7 +5330,7 @@
                 <a:ea typeface="Calibri" pitchFamily="34" charset="-122"/>
                 <a:cs typeface="Calibri" pitchFamily="34" charset="-120"/>
               </a:rPr>
-              <a:t>Separate a calm question from an angry customer, so frustrated and escalatory messages reach the front of the queue.</a:t>
+              <a:t>Frustrated or escalating customers can be flagged, so a person looks at them sooner.</a:t>
             </a:r>
             <a:endParaRPr lang="en-US" sz="1400" dirty="0"/>
           </a:p>
@@ -5365,7 +5402,7 @@
       </p:sp>
       <p:pic>
         <p:nvPicPr>
-          <p:cNvPr id="10" name="Image 1" descr="Measure how messages are handled"/>
+          <p:cNvPr id="10" name="Image 1" descr="Help write better replies"/>
           <p:cNvPicPr>
             <a:picLocks noChangeAspect="1"/>
           </p:cNvPicPr>
@@ -5420,7 +5457,7 @@
                 <a:ea typeface="Cambria" pitchFamily="34" charset="-122"/>
                 <a:cs typeface="Cambria" pitchFamily="34" charset="-120"/>
               </a:rPr>
-              <a:t>Measure how messages are handled</a:t>
+              <a:t>Help write better replies</a:t>
             </a:r>
             <a:endParaRPr lang="en-US" sz="2000" dirty="0"/>
           </a:p>
@@ -5459,7 +5496,7 @@
                 <a:ea typeface="Calibri" pitchFamily="34" charset="-122"/>
                 <a:cs typeface="Calibri" pitchFamily="34" charset="-120"/>
               </a:rPr>
-              <a:t>See whether agent replies calm customers down or make things worse, and coach the team with real examples.</a:t>
+              <a:t>Knowing a customer is upset helps an agent or a bot reply the right way, or hand over to a human.</a:t>
             </a:r>
             <a:endParaRPr lang="en-US" sz="1400" dirty="0"/>
           </a:p>
@@ -5531,14 +5568,14 @@
       </p:sp>
       <p:pic>
         <p:nvPicPr>
-          <p:cNvPr id="15" name="Image 2" descr="Retain customers, protect reputation"/>
+          <p:cNvPr id="15" name="Image 2" descr="Find repeated problems"/>
           <p:cNvPicPr>
             <a:picLocks noChangeAspect="1"/>
           </p:cNvPicPr>
           <p:nvPr/>
         </p:nvPicPr>
         <p:blipFill>
-          <a:blip r:embed="rId5"/>
+          <a:blip r:embed="rId6"/>
           <a:stretch>
             <a:fillRect/>
           </a:stretch>
@@ -5586,7 +5623,7 @@
                 <a:ea typeface="Cambria" pitchFamily="34" charset="-122"/>
                 <a:cs typeface="Cambria" pitchFamily="34" charset="-120"/>
               </a:rPr>
-              <a:t>Retain customers, protect reputation</a:t>
+              <a:t>Find repeated problems</a:t>
             </a:r>
             <a:endParaRPr lang="en-US" sz="2000" dirty="0"/>
           </a:p>
@@ -5625,7 +5662,7 @@
                 <a:ea typeface="Calibri" pitchFamily="34" charset="-122"/>
                 <a:cs typeface="Calibri" pitchFamily="34" charset="-120"/>
               </a:rPr>
-              <a:t>Keeping a customer is the hardest part in a competitive market. Twitter support is public, so poor responses are visible to everyone.</a:t>
+              <a:t>Many upset customers about the same issue, like late deliveries or refunds, point to something worth fixing.</a:t>
             </a:r>
             <a:endParaRPr lang="en-US" sz="1400" dirty="0"/>
           </a:p>
@@ -5697,14 +5734,14 @@
       </p:sp>
       <p:pic>
         <p:nvPicPr>
-          <p:cNvPr id="20" name="Image 3" descr="Reveal system problems"/>
+          <p:cNvPr id="20" name="Image 3" descr="New labels for a hard problem"/>
           <p:cNvPicPr>
             <a:picLocks noChangeAspect="1"/>
           </p:cNvPicPr>
           <p:nvPr/>
         </p:nvPicPr>
         <p:blipFill>
-          <a:blip r:embed="rId6"/>
+          <a:blip r:embed="rId7"/>
           <a:stretch>
             <a:fillRect/>
           </a:stretch>
@@ -5752,7 +5789,7 @@
                 <a:ea typeface="Cambria" pitchFamily="34" charset="-122"/>
                 <a:cs typeface="Cambria" pitchFamily="34" charset="-120"/>
               </a:rPr>
-              <a:t>Reveal system problems</a:t>
+              <a:t>New labels for a hard problem</a:t>
             </a:r>
             <a:endParaRPr lang="en-US" sz="2000" dirty="0"/>
           </a:p>
@@ -5791,7 +5828,7 @@
                 <a:ea typeface="Calibri" pitchFamily="34" charset="-122"/>
                 <a:cs typeface="Calibri" pitchFamily="34" charset="-120"/>
               </a:rPr>
-              <a:t>Many frustrated messages about the same issue, such as late deliveries or refunds, can point to a system or process fault.</a:t>
+              <a:t>2.8M support tweets, zero tone labels. “Thanks a lot” can be praise or sarcasm, so you need the whole conversation.</a:t>
             </a:r>
             <a:endParaRPr lang="en-US" sz="1400" dirty="0"/>
           </a:p>
@@ -5943,7 +5980,7 @@
                 <a:ea typeface="Calibri" pitchFamily="34" charset="-122"/>
                 <a:cs typeface="Calibri" pitchFamily="34" charset="-120"/>
               </a:rPr>
-              <a:t>Read a customer-support conversation and label the customer's tone, based on how the customer ends the conversation.</a:t>
+              <a:t>Classify the customer's overall tone across the complete conversation. Agent replies provide context; the last message alone may be misleading.</a:t>
             </a:r>
             <a:endParaRPr lang="en-US" sz="2000" dirty="0"/>
           </a:p>
@@ -6887,18 +6924,7 @@
                 <a:ea typeface="Calibri" pitchFamily="34" charset="-122"/>
                 <a:cs typeface="Calibri" pitchFamily="34" charset="-120"/>
               </a:rPr>
-              <a:t>If more than one tone fits, use this order: </a:t>
-            </a:r>
-            <a:r>
-              <a:rPr lang="en-US" sz="1800" dirty="0">
-                <a:solidFill>
-                  <a:schemeClr val="tx1"/>
-                </a:solidFill>
-                <a:latin typeface="Calibri" pitchFamily="34" charset="0"/>
-                <a:ea typeface="Calibri" pitchFamily="34" charset="-122"/>
-                <a:cs typeface="Calibri" pitchFamily="34" charset="-120"/>
-              </a:rPr>
-              <a:t>Escalatory, Frustrated, Help-seeking, Appreciative, Neutral.</a:t>
+              <a:t>When multiple tones apply across the exchange: Escalatory, Frustrated, Help-seeking, Appreciative, Neutral.</a:t>
             </a:r>
             <a:endParaRPr lang="en-US" sz="1800" dirty="0"/>
           </a:p>
@@ -7358,7 +7384,7 @@
               <a:buNone/>
             </a:pPr>
             <a:r>
-              <a:rPr lang="en-US" sz="1400" dirty="0">
+              <a:rPr lang="en-US" sz="1500" dirty="0">
                 <a:solidFill>
                   <a:schemeClr val="tx2"/>
                 </a:solidFill>
@@ -7395,7 +7421,7 @@
               <a:buNone/>
             </a:pPr>
             <a:r>
-              <a:rPr lang="en-US" sz="1400" dirty="0">
+              <a:rPr lang="en-US" sz="1500" dirty="0">
                 <a:solidFill>
                   <a:schemeClr val="tx2"/>
                 </a:solidFill>
@@ -7432,7 +7458,7 @@
               <a:buNone/>
             </a:pPr>
             <a:r>
-              <a:rPr lang="en-US" sz="1400" dirty="0">
+              <a:rPr lang="en-US" sz="1500" dirty="0">
                 <a:solidFill>
                   <a:schemeClr val="tx2"/>
                 </a:solidFill>
@@ -7440,7 +7466,7 @@
                 <a:ea typeface="Calibri" pitchFamily="34" charset="-122"/>
                 <a:cs typeface="Calibri" pitchFamily="34" charset="-120"/>
               </a:rPr>
-              <a:t>The customer asks for nothing and volunteers enthusiasm, then closes with "Awesome thanks". Everything points to satisfaction.</a:t>
+              <a:t>The customer expresses enthusiasm in both messages, praising the movie and saying “Awesome thanks”. The exchange supports an Appreciative label.</a:t>
             </a:r>
             <a:endParaRPr lang="en-US" sz="1600" dirty="0"/>
           </a:p>
@@ -7455,7 +7481,7 @@
         <p:spPr>
           <a:xfrm>
             <a:off x="5852160" y="2148840"/>
-            <a:ext cx="5760720" cy="640080"/>
+            <a:ext cx="5760720" cy="932688"/>
           </a:xfrm>
           <a:prstGeom prst="roundRect">
             <a:avLst>
@@ -7472,14 +7498,16 @@
           </a:ln>
         </p:spPr>
         <p:txBody>
-          <a:bodyPr wrap="square" lIns="381" tIns="2540" rIns="2540" bIns="381" rtlCol="0" anchor="ctr"/>
+          <a:bodyPr wrap="square" lIns="381" tIns="2540" rIns="2540" bIns="381" rtlCol="0" anchor="ctr">
+            <a:noAutofit/>
+          </a:bodyPr>
           <a:lstStyle/>
           <a:p>
             <a:pPr marL="0" indent="0">
               <a:buNone/>
             </a:pPr>
             <a:r>
-              <a:rPr lang="en-US" sz="1400" b="1" dirty="0">
+              <a:rPr lang="en-US" sz="1600" b="1" dirty="0">
                 <a:solidFill>
                   <a:schemeClr val="bg1"/>
                 </a:solidFill>
@@ -7490,7 +7518,7 @@
               <a:t>Customer: </a:t>
             </a:r>
             <a:r>
-              <a:rPr lang="en-US" sz="1400" dirty="0">
+              <a:rPr lang="en-US" sz="1600" dirty="0">
                 <a:solidFill>
                   <a:schemeClr val="bg1"/>
                 </a:solidFill>
@@ -7512,8 +7540,8 @@
         </p:nvSpPr>
         <p:spPr>
           <a:xfrm>
-            <a:off x="5029200" y="2907792"/>
-            <a:ext cx="5760720" cy="502920"/>
+            <a:off x="5029200" y="3172968"/>
+            <a:ext cx="5760720" cy="530352"/>
           </a:xfrm>
           <a:prstGeom prst="roundRect">
             <a:avLst>
@@ -7530,14 +7558,16 @@
           </a:ln>
         </p:spPr>
         <p:txBody>
-          <a:bodyPr wrap="square" lIns="381" tIns="2540" rIns="2540" bIns="381" rtlCol="0" anchor="ctr"/>
+          <a:bodyPr wrap="square" lIns="381" tIns="2540" rIns="2540" bIns="381" rtlCol="0" anchor="ctr">
+            <a:noAutofit/>
+          </a:bodyPr>
           <a:lstStyle/>
           <a:p>
             <a:pPr marL="0" indent="0">
               <a:buNone/>
             </a:pPr>
             <a:r>
-              <a:rPr lang="en-US" sz="1400" b="1" dirty="0">
+              <a:rPr lang="en-US" sz="1600" b="1" dirty="0">
                 <a:solidFill>
                   <a:schemeClr val="tx1"/>
                 </a:solidFill>
@@ -7548,7 +7578,7 @@
               <a:t>Support: </a:t>
             </a:r>
             <a:r>
-              <a:rPr lang="en-US" sz="1400" dirty="0">
+              <a:rPr lang="en-US" sz="1600" dirty="0">
                 <a:solidFill>
                   <a:schemeClr val="tx1"/>
                 </a:solidFill>
@@ -7570,8 +7600,8 @@
         </p:nvSpPr>
         <p:spPr>
           <a:xfrm>
-            <a:off x="5852160" y="3529584"/>
-            <a:ext cx="5760720" cy="502920"/>
+            <a:off x="5852160" y="3794760"/>
+            <a:ext cx="5760720" cy="530352"/>
           </a:xfrm>
           <a:prstGeom prst="roundRect">
             <a:avLst>
@@ -7588,14 +7618,16 @@
           </a:ln>
         </p:spPr>
         <p:txBody>
-          <a:bodyPr wrap="square" lIns="381" tIns="2540" rIns="2540" bIns="381" rtlCol="0" anchor="ctr"/>
+          <a:bodyPr wrap="square" lIns="381" tIns="2540" rIns="2540" bIns="381" rtlCol="0" anchor="ctr">
+            <a:noAutofit/>
+          </a:bodyPr>
           <a:lstStyle/>
           <a:p>
             <a:pPr marL="0" indent="0">
               <a:buNone/>
             </a:pPr>
             <a:r>
-              <a:rPr lang="en-US" sz="1400" b="1" dirty="0">
+              <a:rPr lang="en-US" sz="1600" b="1" dirty="0">
                 <a:solidFill>
                   <a:schemeClr val="bg1"/>
                 </a:solidFill>
@@ -7606,7 +7638,7 @@
               <a:t>Customer: </a:t>
             </a:r>
             <a:r>
-              <a:rPr lang="en-US" sz="1400" dirty="0">
+              <a:rPr lang="en-US" sz="1600" dirty="0">
                 <a:solidFill>
                   <a:schemeClr val="bg1"/>
                 </a:solidFill>
@@ -7628,8 +7660,8 @@
         </p:nvSpPr>
         <p:spPr>
           <a:xfrm>
-            <a:off x="5029200" y="4151376"/>
-            <a:ext cx="5760720" cy="502920"/>
+            <a:off x="5029200" y="4416552"/>
+            <a:ext cx="5760720" cy="530352"/>
           </a:xfrm>
           <a:prstGeom prst="roundRect">
             <a:avLst>
@@ -7646,14 +7678,16 @@
           </a:ln>
         </p:spPr>
         <p:txBody>
-          <a:bodyPr wrap="square" lIns="381" tIns="2540" rIns="2540" bIns="381" rtlCol="0" anchor="ctr"/>
+          <a:bodyPr wrap="square" lIns="381" tIns="2540" rIns="2540" bIns="381" rtlCol="0" anchor="ctr">
+            <a:noAutofit/>
+          </a:bodyPr>
           <a:lstStyle/>
           <a:p>
             <a:pPr marL="0" indent="0">
               <a:buNone/>
             </a:pPr>
             <a:r>
-              <a:rPr lang="en-US" sz="1400" b="1" dirty="0">
+              <a:rPr lang="en-US" sz="1600" b="1" dirty="0">
                 <a:solidFill>
                   <a:schemeClr val="tx1"/>
                 </a:solidFill>
@@ -7664,7 +7698,7 @@
               <a:t>Support: </a:t>
             </a:r>
             <a:r>
-              <a:rPr lang="en-US" sz="1400" dirty="0">
+              <a:rPr lang="en-US" sz="1600" dirty="0">
                 <a:solidFill>
                   <a:schemeClr val="tx1"/>
                 </a:solidFill>
@@ -8377,7 +8411,7 @@
               <a:buNone/>
             </a:pPr>
             <a:r>
-              <a:rPr lang="en-US" sz="1400" dirty="0">
+              <a:rPr lang="en-US" sz="1500" dirty="0">
                 <a:solidFill>
                   <a:schemeClr val="tx2"/>
                 </a:solidFill>
@@ -8414,7 +8448,7 @@
               <a:buNone/>
             </a:pPr>
             <a:r>
-              <a:rPr lang="en-US" sz="1400" dirty="0">
+              <a:rPr lang="en-US" sz="1500" dirty="0">
                 <a:solidFill>
                   <a:schemeClr val="tx2"/>
                 </a:solidFill>
@@ -8451,7 +8485,7 @@
               <a:buNone/>
             </a:pPr>
             <a:r>
-              <a:rPr lang="en-US" sz="1400" dirty="0">
+              <a:rPr lang="en-US" sz="1500" dirty="0">
                 <a:solidFill>
                   <a:schemeClr val="tx2"/>
                 </a:solidFill>
@@ -8474,7 +8508,7 @@
         <p:spPr>
           <a:xfrm>
             <a:off x="5852160" y="2148840"/>
-            <a:ext cx="5760720" cy="640080"/>
+            <a:ext cx="5760720" cy="932688"/>
           </a:xfrm>
           <a:prstGeom prst="roundRect">
             <a:avLst>
@@ -8491,14 +8525,16 @@
           </a:ln>
         </p:spPr>
         <p:txBody>
-          <a:bodyPr wrap="square" lIns="381" tIns="2540" rIns="2540" bIns="381" rtlCol="0" anchor="ctr"/>
+          <a:bodyPr wrap="square" lIns="381" tIns="2540" rIns="2540" bIns="381" rtlCol="0" anchor="ctr">
+            <a:noAutofit/>
+          </a:bodyPr>
           <a:lstStyle/>
           <a:p>
             <a:pPr marL="0" indent="0">
               <a:buNone/>
             </a:pPr>
             <a:r>
-              <a:rPr lang="en-US" sz="1400" b="1" dirty="0">
+              <a:rPr lang="en-US" sz="1600" b="1" dirty="0">
                 <a:solidFill>
                   <a:schemeClr val="bg1"/>
                 </a:solidFill>
@@ -8509,7 +8545,7 @@
               <a:t>Customer: </a:t>
             </a:r>
             <a:r>
-              <a:rPr lang="en-US" sz="1400" dirty="0">
+              <a:rPr lang="en-US" sz="1600" dirty="0">
                 <a:solidFill>
                   <a:schemeClr val="bg1"/>
                 </a:solidFill>
@@ -8531,8 +8567,8 @@
         </p:nvSpPr>
         <p:spPr>
           <a:xfrm>
-            <a:off x="5029200" y="2907792"/>
-            <a:ext cx="5760720" cy="640080"/>
+            <a:off x="5029200" y="3172968"/>
+            <a:ext cx="5760720" cy="932688"/>
           </a:xfrm>
           <a:prstGeom prst="roundRect">
             <a:avLst>
@@ -8549,14 +8585,16 @@
           </a:ln>
         </p:spPr>
         <p:txBody>
-          <a:bodyPr wrap="square" lIns="381" tIns="2540" rIns="2540" bIns="381" rtlCol="0" anchor="ctr"/>
+          <a:bodyPr wrap="square" lIns="381" tIns="2540" rIns="2540" bIns="381" rtlCol="0" anchor="ctr">
+            <a:noAutofit/>
+          </a:bodyPr>
           <a:lstStyle/>
           <a:p>
             <a:pPr marL="0" indent="0">
               <a:buNone/>
             </a:pPr>
             <a:r>
-              <a:rPr lang="en-US" sz="1400" b="1" dirty="0">
+              <a:rPr lang="en-US" sz="1600" b="1" dirty="0">
                 <a:solidFill>
                   <a:schemeClr val="tx1"/>
                 </a:solidFill>
@@ -8567,7 +8605,7 @@
               <a:t>Support: </a:t>
             </a:r>
             <a:r>
-              <a:rPr lang="en-US" sz="1400" dirty="0">
+              <a:rPr lang="en-US" sz="1600" dirty="0">
                 <a:solidFill>
                   <a:schemeClr val="tx1"/>
                 </a:solidFill>
@@ -8589,8 +8627,8 @@
         </p:nvSpPr>
         <p:spPr>
           <a:xfrm>
-            <a:off x="5852160" y="3666744"/>
-            <a:ext cx="5760720" cy="502920"/>
+            <a:off x="5852160" y="4197096"/>
+            <a:ext cx="5760720" cy="530352"/>
           </a:xfrm>
           <a:prstGeom prst="roundRect">
             <a:avLst>
@@ -8607,14 +8645,16 @@
           </a:ln>
         </p:spPr>
         <p:txBody>
-          <a:bodyPr wrap="square" lIns="381" tIns="2540" rIns="2540" bIns="381" rtlCol="0" anchor="ctr"/>
+          <a:bodyPr wrap="square" lIns="381" tIns="2540" rIns="2540" bIns="381" rtlCol="0" anchor="ctr">
+            <a:noAutofit/>
+          </a:bodyPr>
           <a:lstStyle/>
           <a:p>
             <a:pPr marL="0" indent="0">
               <a:buNone/>
             </a:pPr>
             <a:r>
-              <a:rPr lang="en-US" sz="1400" b="1" dirty="0">
+              <a:rPr lang="en-US" sz="1600" b="1" dirty="0">
                 <a:solidFill>
                   <a:schemeClr val="bg1"/>
                 </a:solidFill>
@@ -8625,7 +8665,7 @@
               <a:t>Customer: </a:t>
             </a:r>
             <a:r>
-              <a:rPr lang="en-US" sz="1400" dirty="0">
+              <a:rPr lang="en-US" sz="1600" dirty="0">
                 <a:solidFill>
                   <a:schemeClr val="bg1"/>
                 </a:solidFill>
@@ -8647,8 +8687,8 @@
         </p:nvSpPr>
         <p:spPr>
           <a:xfrm>
-            <a:off x="5029200" y="4288536"/>
-            <a:ext cx="5760720" cy="640080"/>
+            <a:off x="5029200" y="4818888"/>
+            <a:ext cx="5760720" cy="749808"/>
           </a:xfrm>
           <a:prstGeom prst="roundRect">
             <a:avLst>
@@ -8665,14 +8705,16 @@
           </a:ln>
         </p:spPr>
         <p:txBody>
-          <a:bodyPr wrap="square" lIns="381" tIns="2540" rIns="2540" bIns="381" rtlCol="0" anchor="ctr"/>
+          <a:bodyPr wrap="square" lIns="381" tIns="2540" rIns="2540" bIns="381" rtlCol="0" anchor="ctr">
+            <a:noAutofit/>
+          </a:bodyPr>
           <a:lstStyle/>
           <a:p>
             <a:pPr marL="0" indent="0">
               <a:buNone/>
             </a:pPr>
             <a:r>
-              <a:rPr lang="en-US" sz="1400" b="1" dirty="0">
+              <a:rPr lang="en-US" sz="1600" b="1" dirty="0">
                 <a:solidFill>
                   <a:schemeClr val="tx1"/>
                 </a:solidFill>
@@ -8683,7 +8725,7 @@
               <a:t>Support: </a:t>
             </a:r>
             <a:r>
-              <a:rPr lang="en-US" sz="1400" dirty="0">
+              <a:rPr lang="en-US" sz="1600" dirty="0">
                 <a:solidFill>
                   <a:schemeClr val="tx1"/>
                 </a:solidFill>
@@ -9396,7 +9438,7 @@
               <a:buNone/>
             </a:pPr>
             <a:r>
-              <a:rPr lang="en-US" sz="1400" dirty="0">
+              <a:rPr lang="en-US" sz="1500" dirty="0">
                 <a:solidFill>
                   <a:schemeClr val="tx2"/>
                 </a:solidFill>
@@ -9433,7 +9475,7 @@
               <a:buNone/>
             </a:pPr>
             <a:r>
-              <a:rPr lang="en-US" sz="1400" dirty="0">
+              <a:rPr lang="en-US" sz="1500" dirty="0">
                 <a:solidFill>
                   <a:schemeClr val="tx2"/>
                 </a:solidFill>
@@ -9470,7 +9512,7 @@
               <a:buNone/>
             </a:pPr>
             <a:r>
-              <a:rPr lang="en-US" sz="1400" dirty="0">
+              <a:rPr lang="en-US" sz="1500" dirty="0">
                 <a:solidFill>
                   <a:schemeClr val="tx2"/>
                 </a:solidFill>
@@ -9493,7 +9535,7 @@
         <p:spPr>
           <a:xfrm>
             <a:off x="5852160" y="2148840"/>
-            <a:ext cx="5760720" cy="640080"/>
+            <a:ext cx="5760720" cy="749808"/>
           </a:xfrm>
           <a:prstGeom prst="roundRect">
             <a:avLst>
@@ -9510,14 +9552,16 @@
           </a:ln>
         </p:spPr>
         <p:txBody>
-          <a:bodyPr wrap="square" lIns="381" tIns="2540" rIns="2540" bIns="381" rtlCol="0" anchor="ctr"/>
+          <a:bodyPr wrap="square" lIns="381" tIns="2540" rIns="2540" bIns="381" rtlCol="0" anchor="ctr">
+            <a:noAutofit/>
+          </a:bodyPr>
           <a:lstStyle/>
           <a:p>
             <a:pPr marL="0" indent="0">
               <a:buNone/>
             </a:pPr>
             <a:r>
-              <a:rPr lang="en-US" sz="1400" b="1" dirty="0">
+              <a:rPr lang="en-US" sz="1600" b="1" dirty="0">
                 <a:solidFill>
                   <a:schemeClr val="bg1"/>
                 </a:solidFill>
@@ -9528,7 +9572,7 @@
               <a:t>Customer: </a:t>
             </a:r>
             <a:r>
-              <a:rPr lang="en-US" sz="1400" dirty="0">
+              <a:rPr lang="en-US" sz="1600" dirty="0">
                 <a:solidFill>
                   <a:schemeClr val="bg1"/>
                 </a:solidFill>
@@ -9550,8 +9594,8 @@
         </p:nvSpPr>
         <p:spPr>
           <a:xfrm>
-            <a:off x="5029200" y="2907792"/>
-            <a:ext cx="5760720" cy="640080"/>
+            <a:off x="5029200" y="2990088"/>
+            <a:ext cx="5760720" cy="749808"/>
           </a:xfrm>
           <a:prstGeom prst="roundRect">
             <a:avLst>
@@ -9568,14 +9612,16 @@
           </a:ln>
         </p:spPr>
         <p:txBody>
-          <a:bodyPr wrap="square" lIns="381" tIns="2540" rIns="2540" bIns="381" rtlCol="0" anchor="ctr"/>
+          <a:bodyPr wrap="square" lIns="381" tIns="2540" rIns="2540" bIns="381" rtlCol="0" anchor="ctr">
+            <a:noAutofit/>
+          </a:bodyPr>
           <a:lstStyle/>
           <a:p>
             <a:pPr marL="0" indent="0">
               <a:buNone/>
             </a:pPr>
             <a:r>
-              <a:rPr lang="en-US" sz="1400" b="1" dirty="0">
+              <a:rPr lang="en-US" sz="1600" b="1" dirty="0">
                 <a:solidFill>
                   <a:schemeClr val="tx1"/>
                 </a:solidFill>
@@ -9586,7 +9632,7 @@
               <a:t>Support: </a:t>
             </a:r>
             <a:r>
-              <a:rPr lang="en-US" sz="1400" dirty="0">
+              <a:rPr lang="en-US" sz="1600" dirty="0">
                 <a:solidFill>
                   <a:schemeClr val="tx1"/>
                 </a:solidFill>
@@ -9608,8 +9654,8 @@
         </p:nvSpPr>
         <p:spPr>
           <a:xfrm>
-            <a:off x="5852160" y="3666744"/>
-            <a:ext cx="5760720" cy="502920"/>
+            <a:off x="5852160" y="3831335"/>
+            <a:ext cx="5760720" cy="749808"/>
           </a:xfrm>
           <a:prstGeom prst="roundRect">
             <a:avLst>
@@ -9626,14 +9672,16 @@
           </a:ln>
         </p:spPr>
         <p:txBody>
-          <a:bodyPr wrap="square" lIns="381" tIns="2540" rIns="2540" bIns="381" rtlCol="0" anchor="ctr"/>
+          <a:bodyPr wrap="square" lIns="381" tIns="2540" rIns="2540" bIns="381" rtlCol="0" anchor="ctr">
+            <a:noAutofit/>
+          </a:bodyPr>
           <a:lstStyle/>
           <a:p>
             <a:pPr marL="0" indent="0">
               <a:buNone/>
             </a:pPr>
             <a:r>
-              <a:rPr lang="en-US" sz="1400" b="1" dirty="0">
+              <a:rPr lang="en-US" sz="1600" b="1" dirty="0">
                 <a:solidFill>
                   <a:schemeClr val="bg1"/>
                 </a:solidFill>
@@ -9644,7 +9692,7 @@
               <a:t>Customer: </a:t>
             </a:r>
             <a:r>
-              <a:rPr lang="en-US" sz="1400" dirty="0">
+              <a:rPr lang="en-US" sz="1600" dirty="0">
                 <a:solidFill>
                   <a:schemeClr val="bg1"/>
                 </a:solidFill>
@@ -9666,8 +9714,8 @@
         </p:nvSpPr>
         <p:spPr>
           <a:xfrm>
-            <a:off x="5029200" y="4288536"/>
-            <a:ext cx="5760720" cy="640080"/>
+            <a:off x="5029200" y="4672583"/>
+            <a:ext cx="5760720" cy="749808"/>
           </a:xfrm>
           <a:prstGeom prst="roundRect">
             <a:avLst>
@@ -9684,14 +9732,16 @@
           </a:ln>
         </p:spPr>
         <p:txBody>
-          <a:bodyPr wrap="square" lIns="381" tIns="2540" rIns="2540" bIns="381" rtlCol="0" anchor="ctr"/>
+          <a:bodyPr wrap="square" lIns="381" tIns="2540" rIns="2540" bIns="381" rtlCol="0" anchor="ctr">
+            <a:noAutofit/>
+          </a:bodyPr>
           <a:lstStyle/>
           <a:p>
             <a:pPr marL="0" indent="0">
               <a:buNone/>
             </a:pPr>
             <a:r>
-              <a:rPr lang="en-US" sz="1400" b="1" dirty="0">
+              <a:rPr lang="en-US" sz="1600" b="1" dirty="0">
                 <a:solidFill>
                   <a:schemeClr val="tx1"/>
                 </a:solidFill>
@@ -9702,7 +9752,7 @@
               <a:t>Support: </a:t>
             </a:r>
             <a:r>
-              <a:rPr lang="en-US" sz="1400" dirty="0">
+              <a:rPr lang="en-US" sz="1600" dirty="0">
                 <a:solidFill>
                   <a:schemeClr val="tx1"/>
                 </a:solidFill>
@@ -10415,7 +10465,7 @@
               <a:buNone/>
             </a:pPr>
             <a:r>
-              <a:rPr lang="en-US" sz="1400" dirty="0">
+              <a:rPr lang="en-US" sz="1500" dirty="0">
                 <a:solidFill>
                   <a:schemeClr val="tx2"/>
                 </a:solidFill>
@@ -10452,7 +10502,7 @@
               <a:buNone/>
             </a:pPr>
             <a:r>
-              <a:rPr lang="en-US" sz="1400" dirty="0">
+              <a:rPr lang="en-US" sz="1500" dirty="0">
                 <a:solidFill>
                   <a:schemeClr val="tx2"/>
                 </a:solidFill>
@@ -10489,7 +10539,7 @@
               <a:buNone/>
             </a:pPr>
             <a:r>
-              <a:rPr lang="en-US" sz="1400" dirty="0">
+              <a:rPr lang="en-US" sz="1500" dirty="0">
                 <a:solidFill>
                   <a:schemeClr val="tx2"/>
                 </a:solidFill>
@@ -10512,7 +10562,7 @@
         <p:spPr>
           <a:xfrm>
             <a:off x="5852160" y="2148840"/>
-            <a:ext cx="5760720" cy="640080"/>
+            <a:ext cx="5760720" cy="749808"/>
           </a:xfrm>
           <a:prstGeom prst="roundRect">
             <a:avLst>
@@ -10529,14 +10579,16 @@
           </a:ln>
         </p:spPr>
         <p:txBody>
-          <a:bodyPr wrap="square" lIns="381" tIns="2540" rIns="2540" bIns="381" rtlCol="0" anchor="ctr"/>
+          <a:bodyPr wrap="square" lIns="381" tIns="2540" rIns="2540" bIns="381" rtlCol="0" anchor="ctr">
+            <a:noAutofit/>
+          </a:bodyPr>
           <a:lstStyle/>
           <a:p>
             <a:pPr marL="0" indent="0">
               <a:buNone/>
             </a:pPr>
             <a:r>
-              <a:rPr lang="en-US" sz="1400" b="1" dirty="0">
+              <a:rPr lang="en-US" sz="1600" b="1" dirty="0">
                 <a:solidFill>
                   <a:schemeClr val="bg1"/>
                 </a:solidFill>
@@ -10547,7 +10599,7 @@
               <a:t>Customer: </a:t>
             </a:r>
             <a:r>
-              <a:rPr lang="en-US" sz="1400" dirty="0">
+              <a:rPr lang="en-US" sz="1600" dirty="0">
                 <a:solidFill>
                   <a:schemeClr val="bg1"/>
                 </a:solidFill>
@@ -10569,8 +10621,8 @@
         </p:nvSpPr>
         <p:spPr>
           <a:xfrm>
-            <a:off x="5029200" y="2907792"/>
-            <a:ext cx="5760720" cy="502920"/>
+            <a:off x="5029200" y="2990088"/>
+            <a:ext cx="5760720" cy="749808"/>
           </a:xfrm>
           <a:prstGeom prst="roundRect">
             <a:avLst>
@@ -10587,14 +10639,16 @@
           </a:ln>
         </p:spPr>
         <p:txBody>
-          <a:bodyPr wrap="square" lIns="381" tIns="2540" rIns="2540" bIns="381" rtlCol="0" anchor="ctr"/>
+          <a:bodyPr wrap="square" lIns="381" tIns="2540" rIns="2540" bIns="381" rtlCol="0" anchor="ctr">
+            <a:noAutofit/>
+          </a:bodyPr>
           <a:lstStyle/>
           <a:p>
             <a:pPr marL="0" indent="0">
               <a:buNone/>
             </a:pPr>
             <a:r>
-              <a:rPr lang="en-US" sz="1400" b="1" dirty="0">
+              <a:rPr lang="en-US" sz="1600" b="1" dirty="0">
                 <a:solidFill>
                   <a:schemeClr val="tx1"/>
                 </a:solidFill>
@@ -10605,7 +10659,7 @@
               <a:t>Support: </a:t>
             </a:r>
             <a:r>
-              <a:rPr lang="en-US" sz="1400" dirty="0">
+              <a:rPr lang="en-US" sz="1600" dirty="0">
                 <a:solidFill>
                   <a:schemeClr val="tx1"/>
                 </a:solidFill>
@@ -10627,8 +10681,8 @@
         </p:nvSpPr>
         <p:spPr>
           <a:xfrm>
-            <a:off x="5852160" y="3529584"/>
-            <a:ext cx="5760720" cy="640080"/>
+            <a:off x="5852160" y="3831335"/>
+            <a:ext cx="5760720" cy="749808"/>
           </a:xfrm>
           <a:prstGeom prst="roundRect">
             <a:avLst>
@@ -10645,14 +10699,16 @@
           </a:ln>
         </p:spPr>
         <p:txBody>
-          <a:bodyPr wrap="square" lIns="381" tIns="2540" rIns="2540" bIns="381" rtlCol="0" anchor="ctr"/>
+          <a:bodyPr wrap="square" lIns="381" tIns="2540" rIns="2540" bIns="381" rtlCol="0" anchor="ctr">
+            <a:noAutofit/>
+          </a:bodyPr>
           <a:lstStyle/>
           <a:p>
             <a:pPr marL="0" indent="0">
               <a:buNone/>
             </a:pPr>
             <a:r>
-              <a:rPr lang="en-US" sz="1400" b="1" dirty="0">
+              <a:rPr lang="en-US" sz="1600" b="1" dirty="0">
                 <a:solidFill>
                   <a:schemeClr val="bg1"/>
                 </a:solidFill>
@@ -10663,7 +10719,7 @@
               <a:t>Customer: </a:t>
             </a:r>
             <a:r>
-              <a:rPr lang="en-US" sz="1400" dirty="0">
+              <a:rPr lang="en-US" sz="1600" dirty="0">
                 <a:solidFill>
                   <a:schemeClr val="bg1"/>
                 </a:solidFill>
@@ -10685,8 +10741,8 @@
         </p:nvSpPr>
         <p:spPr>
           <a:xfrm>
-            <a:off x="5029200" y="4288536"/>
-            <a:ext cx="5760720" cy="502920"/>
+            <a:off x="5029200" y="4672583"/>
+            <a:ext cx="5760720" cy="749808"/>
           </a:xfrm>
           <a:prstGeom prst="roundRect">
             <a:avLst>
@@ -10703,14 +10759,16 @@
           </a:ln>
         </p:spPr>
         <p:txBody>
-          <a:bodyPr wrap="square" lIns="381" tIns="2540" rIns="2540" bIns="381" rtlCol="0" anchor="ctr"/>
+          <a:bodyPr wrap="square" lIns="381" tIns="2540" rIns="2540" bIns="381" rtlCol="0" anchor="ctr">
+            <a:noAutofit/>
+          </a:bodyPr>
           <a:lstStyle/>
           <a:p>
             <a:pPr marL="0" indent="0">
               <a:buNone/>
             </a:pPr>
             <a:r>
-              <a:rPr lang="en-US" sz="1400" b="1" dirty="0">
+              <a:rPr lang="en-US" sz="1600" b="1" dirty="0">
                 <a:solidFill>
                   <a:schemeClr val="tx1"/>
                 </a:solidFill>
@@ -10721,7 +10779,7 @@
               <a:t>Support: </a:t>
             </a:r>
             <a:r>
-              <a:rPr lang="en-US" sz="1400" dirty="0">
+              <a:rPr lang="en-US" sz="1600" dirty="0">
                 <a:solidFill>
                   <a:schemeClr val="tx1"/>
                 </a:solidFill>
@@ -11434,7 +11492,7 @@
               <a:buNone/>
             </a:pPr>
             <a:r>
-              <a:rPr lang="en-US" sz="1400" dirty="0">
+              <a:rPr lang="en-US" sz="1500" dirty="0">
                 <a:solidFill>
                   <a:schemeClr val="tx2"/>
                 </a:solidFill>
@@ -11471,7 +11529,7 @@
               <a:buNone/>
             </a:pPr>
             <a:r>
-              <a:rPr lang="en-US" sz="1400" dirty="0">
+              <a:rPr lang="en-US" sz="1500" dirty="0">
                 <a:solidFill>
                   <a:schemeClr val="tx2"/>
                 </a:solidFill>
@@ -11508,7 +11566,7 @@
               <a:buNone/>
             </a:pPr>
             <a:r>
-              <a:rPr lang="en-US" sz="1400" dirty="0">
+              <a:rPr lang="en-US" sz="1500" dirty="0">
                 <a:solidFill>
                   <a:schemeClr val="tx2"/>
                 </a:solidFill>
@@ -11531,7 +11589,7 @@
         <p:spPr>
           <a:xfrm>
             <a:off x="5852160" y="2148840"/>
-            <a:ext cx="5760720" cy="640080"/>
+            <a:ext cx="5760720" cy="777240"/>
           </a:xfrm>
           <a:prstGeom prst="roundRect">
             <a:avLst>
@@ -11548,14 +11606,16 @@
           </a:ln>
         </p:spPr>
         <p:txBody>
-          <a:bodyPr wrap="square" lIns="381" tIns="2540" rIns="2540" bIns="381" rtlCol="0" anchor="ctr"/>
+          <a:bodyPr wrap="square" lIns="381" tIns="2540" rIns="2540" bIns="381" rtlCol="0" anchor="ctr">
+            <a:noAutofit/>
+          </a:bodyPr>
           <a:lstStyle/>
           <a:p>
             <a:pPr marL="0" indent="0">
               <a:buNone/>
             </a:pPr>
             <a:r>
-              <a:rPr lang="en-US" sz="1400" b="1" dirty="0">
+              <a:rPr lang="en-US" sz="1500" b="1" dirty="0">
                 <a:solidFill>
                   <a:schemeClr val="bg1"/>
                 </a:solidFill>
@@ -11566,7 +11626,7 @@
               <a:t>Customer: </a:t>
             </a:r>
             <a:r>
-              <a:rPr lang="en-US" sz="1400" dirty="0">
+              <a:rPr lang="en-US" sz="1500" dirty="0">
                 <a:solidFill>
                   <a:schemeClr val="bg1"/>
                 </a:solidFill>
@@ -11588,8 +11648,8 @@
         </p:nvSpPr>
         <p:spPr>
           <a:xfrm>
-            <a:off x="5029200" y="2907792"/>
-            <a:ext cx="5760720" cy="640080"/>
+            <a:off x="5029200" y="2965399"/>
+            <a:ext cx="5760720" cy="777240"/>
           </a:xfrm>
           <a:prstGeom prst="roundRect">
             <a:avLst>
@@ -11606,14 +11666,16 @@
           </a:ln>
         </p:spPr>
         <p:txBody>
-          <a:bodyPr wrap="square" lIns="381" tIns="2540" rIns="2540" bIns="381" rtlCol="0" anchor="ctr"/>
+          <a:bodyPr wrap="square" lIns="381" tIns="2540" rIns="2540" bIns="381" rtlCol="0" anchor="ctr">
+            <a:noAutofit/>
+          </a:bodyPr>
           <a:lstStyle/>
           <a:p>
             <a:pPr marL="0" indent="0">
               <a:buNone/>
             </a:pPr>
             <a:r>
-              <a:rPr lang="en-US" sz="1400" b="1" dirty="0">
+              <a:rPr lang="en-US" sz="1500" b="1" dirty="0">
                 <a:solidFill>
                   <a:schemeClr val="tx1"/>
                 </a:solidFill>
@@ -11624,7 +11686,7 @@
               <a:t>Support: </a:t>
             </a:r>
             <a:r>
-              <a:rPr lang="en-US" sz="1400" dirty="0">
+              <a:rPr lang="en-US" sz="1500" dirty="0">
                 <a:solidFill>
                   <a:schemeClr val="tx1"/>
                 </a:solidFill>
@@ -11646,8 +11708,8 @@
         </p:nvSpPr>
         <p:spPr>
           <a:xfrm>
-            <a:off x="5852160" y="3666744"/>
-            <a:ext cx="5760720" cy="859536"/>
+            <a:off x="5852160" y="3781958"/>
+            <a:ext cx="5760720" cy="932688"/>
           </a:xfrm>
           <a:prstGeom prst="roundRect">
             <a:avLst>
@@ -11664,14 +11726,16 @@
           </a:ln>
         </p:spPr>
         <p:txBody>
-          <a:bodyPr wrap="square" lIns="381" tIns="2540" rIns="2540" bIns="381" rtlCol="0" anchor="ctr"/>
+          <a:bodyPr wrap="square" lIns="381" tIns="2540" rIns="2540" bIns="381" rtlCol="0" anchor="ctr">
+            <a:noAutofit/>
+          </a:bodyPr>
           <a:lstStyle/>
           <a:p>
             <a:pPr marL="0" indent="0">
               <a:buNone/>
             </a:pPr>
             <a:r>
-              <a:rPr lang="en-US" sz="1400" b="1" dirty="0">
+              <a:rPr lang="en-US" sz="1500" b="1" dirty="0">
                 <a:solidFill>
                   <a:schemeClr val="bg1"/>
                 </a:solidFill>
@@ -11682,7 +11746,7 @@
               <a:t>Customer: </a:t>
             </a:r>
             <a:r>
-              <a:rPr lang="en-US" sz="1400" dirty="0">
+              <a:rPr lang="en-US" sz="1500" dirty="0">
                 <a:solidFill>
                   <a:schemeClr val="bg1"/>
                 </a:solidFill>
@@ -11704,8 +11768,8 @@
         </p:nvSpPr>
         <p:spPr>
           <a:xfrm>
-            <a:off x="5029200" y="4645152"/>
-            <a:ext cx="5760720" cy="640080"/>
+            <a:off x="5029200" y="4744638"/>
+            <a:ext cx="5760720" cy="612648"/>
           </a:xfrm>
           <a:prstGeom prst="roundRect">
             <a:avLst>
@@ -11722,14 +11786,16 @@
           </a:ln>
         </p:spPr>
         <p:txBody>
-          <a:bodyPr wrap="square" lIns="381" tIns="2540" rIns="2540" bIns="381" rtlCol="0" anchor="ctr"/>
+          <a:bodyPr wrap="square" lIns="381" tIns="2540" rIns="2540" bIns="381" rtlCol="0" anchor="ctr">
+            <a:noAutofit/>
+          </a:bodyPr>
           <a:lstStyle/>
           <a:p>
             <a:pPr marL="0" indent="0">
               <a:buNone/>
             </a:pPr>
             <a:r>
-              <a:rPr lang="en-US" sz="1400" b="1" dirty="0">
+              <a:rPr lang="en-US" sz="1500" b="1" dirty="0">
                 <a:solidFill>
                   <a:schemeClr val="tx1"/>
                 </a:solidFill>
@@ -11740,7 +11806,7 @@
               <a:t>Support: </a:t>
             </a:r>
             <a:r>
-              <a:rPr lang="en-US" sz="1400" dirty="0">
+              <a:rPr lang="en-US" sz="1500" dirty="0">
                 <a:solidFill>
                   <a:schemeClr val="tx1"/>
                 </a:solidFill>
@@ -11762,8 +11828,8 @@
         </p:nvSpPr>
         <p:spPr>
           <a:xfrm>
-            <a:off x="5852160" y="5404104"/>
-            <a:ext cx="5760720" cy="640080"/>
+            <a:off x="5852160" y="5406481"/>
+            <a:ext cx="5760720" cy="777240"/>
           </a:xfrm>
           <a:prstGeom prst="roundRect">
             <a:avLst>
@@ -11780,14 +11846,16 @@
           </a:ln>
         </p:spPr>
         <p:txBody>
-          <a:bodyPr wrap="square" lIns="381" tIns="2540" rIns="2540" bIns="381" rtlCol="0" anchor="ctr"/>
+          <a:bodyPr wrap="square" lIns="381" tIns="2540" rIns="2540" bIns="381" rtlCol="0" anchor="ctr">
+            <a:noAutofit/>
+          </a:bodyPr>
           <a:lstStyle/>
           <a:p>
             <a:pPr marL="0" indent="0">
               <a:buNone/>
             </a:pPr>
             <a:r>
-              <a:rPr lang="en-US" sz="1400" b="1" dirty="0">
+              <a:rPr lang="en-US" sz="1500" b="1" dirty="0">
                 <a:solidFill>
                   <a:schemeClr val="bg1"/>
                 </a:solidFill>
@@ -11798,7 +11866,7 @@
               <a:t>Customer: </a:t>
             </a:r>
             <a:r>
-              <a:rPr lang="en-US" sz="1400" dirty="0">
+              <a:rPr lang="en-US" sz="1500" dirty="0">
                 <a:solidFill>
                   <a:schemeClr val="bg1"/>
                 </a:solidFill>

</xml_diff>

<commit_message>
Update Customer Tone Annotation Guidelines.md: Clarified instructions for labeling customer tones by specifying that the focus is on the customer's last message, adjusted the order of precedence for tone classification, and refined examples to enhance understanding of tone determination.
</commit_message>
<xml_diff>
--- a/docs/Phase 1 PPT.pptx
+++ b/docs/Phase 1 PPT.pptx
@@ -957,7 +957,7 @@
           <a:p>
             <a:r>
               <a:rPr lang="en-US" dirty="0"/>
-              <a:t>Explain the redundancy versus coverage choice: 20 conversations labeled by all six, 10 by pairs, 5 by triples, and 65 unique per batch. Annotators run Potato locally and send back annotation_output.</a:t>
+              <a:t>Explain the redundancy versus coverage choice: 30 conversations labeled by all six (6 labels each, for agreement and a majority vote) and 70 unique per annotator per batch. 450 distinct conversations per round. Annotators run Potato locally and send back annotation_output.</a:t>
             </a:r>
           </a:p>
         </p:txBody>
@@ -1161,7 +1161,7 @@
           <a:p>
             <a:r>
               <a:rPr lang="en-US" dirty="0"/>
-              <a:t>And it is not easy: “Thanks a lot” after a useless reply is sarcasm, not praise. That is why you read the whole conversation.</a:t>
+              <a:t>And it is not easy: “Thanks a lot” after a useless reply is sarcasm, not praise. That is why earlier messages matter when the last one is unclear.</a:t>
             </a:r>
           </a:p>
           <a:p>
@@ -1254,7 +1254,7 @@
           <a:p>
             <a:r>
               <a:rPr lang="en-US" dirty="0"/>
-              <a:t>Five labels from calm and positive to angry and demanding. The label is the customer's overall tone across the whole conversation; the last message does not take priority. If tones mix, use the order shown on the slide. Next five slides: one real example per label.</a:t>
+              <a:t>Five labels from calm and positive to angry and demanding. The label is the tone of the customer’s last message. Read earlier turns only when it is unclear, e.g. a bare “thanks” that might be sarcastic, or a one-word reply. If the last message mixes tones, use the order shown on the slide. Next five slides: one real example per label.</a:t>
             </a:r>
           </a:p>
         </p:txBody>
@@ -1341,7 +1341,7 @@
           <a:p>
             <a:r>
               <a:rPr lang="en-US" dirty="0"/>
-              <a:t>Click once to show the whole conversation, then once more to show the guide panel. 1. Appreciative or positive: The customer expresses enthusiasm in both messages, praising the movie and saying “Awesome thanks”. They ask for nothing, so the exchange supports an Appreciative label.</a:t>
+              <a:t>Click once to show the whole conversation, then once more to show the guide panel. 1. Appreciative or positive: The last message, “Awesome thanks”, is genuine enthusiasm. The earlier praise for the movie confirms it is not sarcasm.</a:t>
             </a:r>
           </a:p>
         </p:txBody>
@@ -3117,7 +3117,7 @@
                 <a:ea typeface="Calibri" pitchFamily="34" charset="-122"/>
                 <a:cs typeface="Calibri" pitchFamily="34" charset="-120"/>
               </a:rPr>
-              <a:t>Read the whole conversation first; agent replies are context.</a:t>
+              <a:t>Start with the customer’s last message; earlier turns are context.</a:t>
             </a:r>
             <a:endParaRPr lang="en-US" sz="1500" dirty="0"/>
           </a:p>
@@ -3337,7 +3337,7 @@
                 <a:ea typeface="Calibri" pitchFamily="34" charset="-122"/>
                 <a:cs typeface="Calibri" pitchFamily="34" charset="-120"/>
               </a:rPr>
-              <a:t>Label the customer's tone across the whole conversation.</a:t>
+              <a:t>If the last message is unclear, use the earlier conversation to decide.</a:t>
             </a:r>
             <a:endParaRPr lang="en-US" sz="1500" dirty="0"/>
           </a:p>
@@ -3447,7 +3447,7 @@
                 <a:ea typeface="Calibri" pitchFamily="34" charset="-122"/>
                 <a:cs typeface="Calibri" pitchFamily="34" charset="-120"/>
               </a:rPr>
-              <a:t>If tones mix, use this order: Escalatory, Frustrated, Help-seeking, Appreciative, Neutral.</a:t>
+              <a:t>If the last message mixes tones, use this order: Escalatory, Frustrated, Help-seeking, Appreciative, Neutral.</a:t>
             </a:r>
             <a:endParaRPr lang="en-US" sz="1500" dirty="0"/>
           </a:p>
@@ -3657,7 +3657,7 @@
         </p:nvGraphicFramePr>
         <p:xfrm>
           <a:off x="6400800" y="2560320"/>
-          <a:ext cx="5212080" cy="2286000"/>
+          <a:ext cx="5212080" cy="1371600"/>
         </p:xfrm>
         <a:graphic>
           <a:graphicData uri="http://schemas.openxmlformats.org/drawingml/2006/table">
@@ -3983,7 +3983,7 @@
                           <a:ea typeface="Calibri" pitchFamily="34" charset="-122"/>
                           <a:cs typeface="Calibri" pitchFamily="34" charset="-120"/>
                         </a:rPr>
-                        <a:t>20</a:t>
+                        <a:t>30</a:t>
                       </a:r>
                       <a:endParaRPr lang="en-US" sz="1400" dirty="0">
                         <a:latin typeface="Calibri" charset="0"/>
@@ -4126,428 +4126,6 @@
                           <a:ea typeface="Calibri" pitchFamily="34" charset="-122"/>
                           <a:cs typeface="Calibri" pitchFamily="34" charset="-120"/>
                         </a:rPr>
-                        <a:t>Pair</a:t>
-                      </a:r>
-                      <a:endParaRPr lang="en-US" sz="1400" dirty="0">
-                        <a:latin typeface="Calibri" charset="0"/>
-                        <a:ea typeface="Calibri" charset="0"/>
-                        <a:cs typeface="Calibri" charset="0"/>
-                      </a:endParaRPr>
-                    </a:p>
-                  </a:txBody>
-                  <a:tcPr marL="109728" marR="109728" marT="0" marB="0" anchor="ctr">
-                    <a:lnL w="12700" cap="flat" cmpd="sng" algn="ctr">
-                      <a:solidFill>
-                        <a:srgbClr val="BBBBBB"/>
-                      </a:solidFill>
-                      <a:prstDash val="solid"/>
-                      <a:round/>
-                      <a:headEnd type="none" w="med" len="med"/>
-                      <a:tailEnd type="none" w="med" len="med"/>
-                    </a:lnL>
-                    <a:lnR w="12700" cap="flat" cmpd="sng" algn="ctr">
-                      <a:solidFill>
-                        <a:srgbClr val="BBBBBB"/>
-                      </a:solidFill>
-                      <a:prstDash val="solid"/>
-                      <a:round/>
-                      <a:headEnd type="none" w="med" len="med"/>
-                      <a:tailEnd type="none" w="med" len="med"/>
-                    </a:lnR>
-                    <a:lnT w="12700" cap="flat" cmpd="sng" algn="ctr">
-                      <a:solidFill>
-                        <a:srgbClr val="BBBBBB"/>
-                      </a:solidFill>
-                      <a:prstDash val="solid"/>
-                      <a:round/>
-                      <a:headEnd type="none" w="med" len="med"/>
-                      <a:tailEnd type="none" w="med" len="med"/>
-                    </a:lnT>
-                    <a:lnB w="12700" cap="flat" cmpd="sng" algn="ctr">
-                      <a:solidFill>
-                        <a:srgbClr val="BBBBBB"/>
-                      </a:solidFill>
-                      <a:prstDash val="solid"/>
-                      <a:round/>
-                      <a:headEnd type="none" w="med" len="med"/>
-                      <a:tailEnd type="none" w="med" len="med"/>
-                    </a:lnB>
-                    <a:solidFill>
-                      <a:srgbClr val="FFFFFF"/>
-                    </a:solidFill>
-                  </a:tcPr>
-                </a:tc>
-                <a:tc>
-                  <a:txBody>
-                    <a:bodyPr/>
-                    <a:lstStyle/>
-                    <a:p>
-                      <a:pPr marL="0" indent="0">
-                        <a:buNone/>
-                      </a:pPr>
-                      <a:r>
-                        <a:rPr lang="en-US" sz="1400" dirty="0">
-                          <a:solidFill>
-                            <a:srgbClr val="000000"/>
-                          </a:solidFill>
-                          <a:latin typeface="Calibri" pitchFamily="34" charset="0"/>
-                          <a:ea typeface="Calibri" pitchFamily="34" charset="-122"/>
-                          <a:cs typeface="Calibri" pitchFamily="34" charset="-120"/>
-                        </a:rPr>
-                        <a:t>10</a:t>
-                      </a:r>
-                      <a:endParaRPr lang="en-US" sz="1400" dirty="0">
-                        <a:latin typeface="Calibri" charset="0"/>
-                        <a:ea typeface="Calibri" charset="0"/>
-                        <a:cs typeface="Calibri" charset="0"/>
-                      </a:endParaRPr>
-                    </a:p>
-                  </a:txBody>
-                  <a:tcPr marL="109728" marR="109728" marT="0" marB="0" anchor="ctr">
-                    <a:lnL w="12700" cap="flat" cmpd="sng" algn="ctr">
-                      <a:solidFill>
-                        <a:srgbClr val="BBBBBB"/>
-                      </a:solidFill>
-                      <a:prstDash val="solid"/>
-                      <a:round/>
-                      <a:headEnd type="none" w="med" len="med"/>
-                      <a:tailEnd type="none" w="med" len="med"/>
-                    </a:lnL>
-                    <a:lnR w="12700" cap="flat" cmpd="sng" algn="ctr">
-                      <a:solidFill>
-                        <a:srgbClr val="BBBBBB"/>
-                      </a:solidFill>
-                      <a:prstDash val="solid"/>
-                      <a:round/>
-                      <a:headEnd type="none" w="med" len="med"/>
-                      <a:tailEnd type="none" w="med" len="med"/>
-                    </a:lnR>
-                    <a:lnT w="12700" cap="flat" cmpd="sng" algn="ctr">
-                      <a:solidFill>
-                        <a:srgbClr val="BBBBBB"/>
-                      </a:solidFill>
-                      <a:prstDash val="solid"/>
-                      <a:round/>
-                      <a:headEnd type="none" w="med" len="med"/>
-                      <a:tailEnd type="none" w="med" len="med"/>
-                    </a:lnT>
-                    <a:lnB w="12700" cap="flat" cmpd="sng" algn="ctr">
-                      <a:solidFill>
-                        <a:srgbClr val="BBBBBB"/>
-                      </a:solidFill>
-                      <a:prstDash val="solid"/>
-                      <a:round/>
-                      <a:headEnd type="none" w="med" len="med"/>
-                      <a:tailEnd type="none" w="med" len="med"/>
-                    </a:lnB>
-                    <a:solidFill>
-                      <a:srgbClr val="FFFFFF"/>
-                    </a:solidFill>
-                  </a:tcPr>
-                </a:tc>
-                <a:tc>
-                  <a:txBody>
-                    <a:bodyPr/>
-                    <a:lstStyle/>
-                    <a:p>
-                      <a:pPr marL="0" indent="0">
-                        <a:buNone/>
-                      </a:pPr>
-                      <a:r>
-                        <a:rPr lang="en-US" sz="1400" dirty="0">
-                          <a:solidFill>
-                            <a:srgbClr val="000000"/>
-                          </a:solidFill>
-                          <a:latin typeface="Calibri" pitchFamily="34" charset="0"/>
-                          <a:ea typeface="Calibri" pitchFamily="34" charset="-122"/>
-                          <a:cs typeface="Calibri" pitchFamily="34" charset="-120"/>
-                        </a:rPr>
-                        <a:t>2 annotators</a:t>
-                      </a:r>
-                      <a:endParaRPr lang="en-US" sz="1400" dirty="0">
-                        <a:latin typeface="Calibri" charset="0"/>
-                        <a:ea typeface="Calibri" charset="0"/>
-                        <a:cs typeface="Calibri" charset="0"/>
-                      </a:endParaRPr>
-                    </a:p>
-                  </a:txBody>
-                  <a:tcPr marL="109728" marR="109728" marT="0" marB="0" anchor="ctr">
-                    <a:lnL w="12700" cap="flat" cmpd="sng" algn="ctr">
-                      <a:solidFill>
-                        <a:srgbClr val="BBBBBB"/>
-                      </a:solidFill>
-                      <a:prstDash val="solid"/>
-                      <a:round/>
-                      <a:headEnd type="none" w="med" len="med"/>
-                      <a:tailEnd type="none" w="med" len="med"/>
-                    </a:lnL>
-                    <a:lnR w="12700" cap="flat" cmpd="sng" algn="ctr">
-                      <a:solidFill>
-                        <a:srgbClr val="BBBBBB"/>
-                      </a:solidFill>
-                      <a:prstDash val="solid"/>
-                      <a:round/>
-                      <a:headEnd type="none" w="med" len="med"/>
-                      <a:tailEnd type="none" w="med" len="med"/>
-                    </a:lnR>
-                    <a:lnT w="12700" cap="flat" cmpd="sng" algn="ctr">
-                      <a:solidFill>
-                        <a:srgbClr val="BBBBBB"/>
-                      </a:solidFill>
-                      <a:prstDash val="solid"/>
-                      <a:round/>
-                      <a:headEnd type="none" w="med" len="med"/>
-                      <a:tailEnd type="none" w="med" len="med"/>
-                    </a:lnT>
-                    <a:lnB w="12700" cap="flat" cmpd="sng" algn="ctr">
-                      <a:solidFill>
-                        <a:srgbClr val="BBBBBB"/>
-                      </a:solidFill>
-                      <a:prstDash val="solid"/>
-                      <a:round/>
-                      <a:headEnd type="none" w="med" len="med"/>
-                      <a:tailEnd type="none" w="med" len="med"/>
-                    </a:lnB>
-                    <a:solidFill>
-                      <a:srgbClr val="FFFFFF"/>
-                    </a:solidFill>
-                  </a:tcPr>
-                </a:tc>
-                <a:extLst>
-                  <a:ext uri="{0D108BD9-81ED-4DB2-BD59-A6C34878D82A}">
-                    <a16:rowId xmlns:a16="http://schemas.microsoft.com/office/drawing/2014/main" val="10002"/>
-                  </a:ext>
-                </a:extLst>
-              </a:tr>
-              <a:tr h="457200">
-                <a:tc>
-                  <a:txBody>
-                    <a:bodyPr/>
-                    <a:lstStyle/>
-                    <a:p>
-                      <a:pPr marL="0" indent="0">
-                        <a:buNone/>
-                      </a:pPr>
-                      <a:r>
-                        <a:rPr lang="en-US" sz="1400" b="1" dirty="0">
-                          <a:solidFill>
-                            <a:srgbClr val="000000"/>
-                          </a:solidFill>
-                          <a:latin typeface="Calibri" pitchFamily="34" charset="0"/>
-                          <a:ea typeface="Calibri" pitchFamily="34" charset="-122"/>
-                          <a:cs typeface="Calibri" pitchFamily="34" charset="-120"/>
-                        </a:rPr>
-                        <a:t>Triple</a:t>
-                      </a:r>
-                      <a:endParaRPr lang="en-US" sz="1400" dirty="0">
-                        <a:latin typeface="Calibri" charset="0"/>
-                        <a:ea typeface="Calibri" charset="0"/>
-                        <a:cs typeface="Calibri" charset="0"/>
-                      </a:endParaRPr>
-                    </a:p>
-                  </a:txBody>
-                  <a:tcPr marL="109728" marR="109728" marT="0" marB="0" anchor="ctr">
-                    <a:lnL w="12700" cap="flat" cmpd="sng" algn="ctr">
-                      <a:solidFill>
-                        <a:srgbClr val="BBBBBB"/>
-                      </a:solidFill>
-                      <a:prstDash val="solid"/>
-                      <a:round/>
-                      <a:headEnd type="none" w="med" len="med"/>
-                      <a:tailEnd type="none" w="med" len="med"/>
-                    </a:lnL>
-                    <a:lnR w="12700" cap="flat" cmpd="sng" algn="ctr">
-                      <a:solidFill>
-                        <a:srgbClr val="BBBBBB"/>
-                      </a:solidFill>
-                      <a:prstDash val="solid"/>
-                      <a:round/>
-                      <a:headEnd type="none" w="med" len="med"/>
-                      <a:tailEnd type="none" w="med" len="med"/>
-                    </a:lnR>
-                    <a:lnT w="12700" cap="flat" cmpd="sng" algn="ctr">
-                      <a:solidFill>
-                        <a:srgbClr val="BBBBBB"/>
-                      </a:solidFill>
-                      <a:prstDash val="solid"/>
-                      <a:round/>
-                      <a:headEnd type="none" w="med" len="med"/>
-                      <a:tailEnd type="none" w="med" len="med"/>
-                    </a:lnT>
-                    <a:lnB w="12700" cap="flat" cmpd="sng" algn="ctr">
-                      <a:solidFill>
-                        <a:srgbClr val="BBBBBB"/>
-                      </a:solidFill>
-                      <a:prstDash val="solid"/>
-                      <a:round/>
-                      <a:headEnd type="none" w="med" len="med"/>
-                      <a:tailEnd type="none" w="med" len="med"/>
-                    </a:lnB>
-                    <a:solidFill>
-                      <a:srgbClr val="FFFFFF"/>
-                    </a:solidFill>
-                  </a:tcPr>
-                </a:tc>
-                <a:tc>
-                  <a:txBody>
-                    <a:bodyPr/>
-                    <a:lstStyle/>
-                    <a:p>
-                      <a:pPr marL="0" indent="0">
-                        <a:buNone/>
-                      </a:pPr>
-                      <a:r>
-                        <a:rPr lang="en-US" sz="1400" dirty="0">
-                          <a:solidFill>
-                            <a:srgbClr val="000000"/>
-                          </a:solidFill>
-                          <a:latin typeface="Calibri" pitchFamily="34" charset="0"/>
-                          <a:ea typeface="Calibri" pitchFamily="34" charset="-122"/>
-                          <a:cs typeface="Calibri" pitchFamily="34" charset="-120"/>
-                        </a:rPr>
-                        <a:t>5</a:t>
-                      </a:r>
-                      <a:endParaRPr lang="en-US" sz="1400" dirty="0">
-                        <a:latin typeface="Calibri" charset="0"/>
-                        <a:ea typeface="Calibri" charset="0"/>
-                        <a:cs typeface="Calibri" charset="0"/>
-                      </a:endParaRPr>
-                    </a:p>
-                  </a:txBody>
-                  <a:tcPr marL="109728" marR="109728" marT="0" marB="0" anchor="ctr">
-                    <a:lnL w="12700" cap="flat" cmpd="sng" algn="ctr">
-                      <a:solidFill>
-                        <a:srgbClr val="BBBBBB"/>
-                      </a:solidFill>
-                      <a:prstDash val="solid"/>
-                      <a:round/>
-                      <a:headEnd type="none" w="med" len="med"/>
-                      <a:tailEnd type="none" w="med" len="med"/>
-                    </a:lnL>
-                    <a:lnR w="12700" cap="flat" cmpd="sng" algn="ctr">
-                      <a:solidFill>
-                        <a:srgbClr val="BBBBBB"/>
-                      </a:solidFill>
-                      <a:prstDash val="solid"/>
-                      <a:round/>
-                      <a:headEnd type="none" w="med" len="med"/>
-                      <a:tailEnd type="none" w="med" len="med"/>
-                    </a:lnR>
-                    <a:lnT w="12700" cap="flat" cmpd="sng" algn="ctr">
-                      <a:solidFill>
-                        <a:srgbClr val="BBBBBB"/>
-                      </a:solidFill>
-                      <a:prstDash val="solid"/>
-                      <a:round/>
-                      <a:headEnd type="none" w="med" len="med"/>
-                      <a:tailEnd type="none" w="med" len="med"/>
-                    </a:lnT>
-                    <a:lnB w="12700" cap="flat" cmpd="sng" algn="ctr">
-                      <a:solidFill>
-                        <a:srgbClr val="BBBBBB"/>
-                      </a:solidFill>
-                      <a:prstDash val="solid"/>
-                      <a:round/>
-                      <a:headEnd type="none" w="med" len="med"/>
-                      <a:tailEnd type="none" w="med" len="med"/>
-                    </a:lnB>
-                    <a:solidFill>
-                      <a:srgbClr val="FFFFFF"/>
-                    </a:solidFill>
-                  </a:tcPr>
-                </a:tc>
-                <a:tc>
-                  <a:txBody>
-                    <a:bodyPr/>
-                    <a:lstStyle/>
-                    <a:p>
-                      <a:pPr marL="0" indent="0">
-                        <a:buNone/>
-                      </a:pPr>
-                      <a:r>
-                        <a:rPr lang="en-US" sz="1400" dirty="0">
-                          <a:solidFill>
-                            <a:srgbClr val="000000"/>
-                          </a:solidFill>
-                          <a:latin typeface="Calibri" pitchFamily="34" charset="0"/>
-                          <a:ea typeface="Calibri" pitchFamily="34" charset="-122"/>
-                          <a:cs typeface="Calibri" pitchFamily="34" charset="-120"/>
-                        </a:rPr>
-                        <a:t>3 annotators</a:t>
-                      </a:r>
-                      <a:endParaRPr lang="en-US" sz="1400" dirty="0">
-                        <a:latin typeface="Calibri" charset="0"/>
-                        <a:ea typeface="Calibri" charset="0"/>
-                        <a:cs typeface="Calibri" charset="0"/>
-                      </a:endParaRPr>
-                    </a:p>
-                  </a:txBody>
-                  <a:tcPr marL="109728" marR="109728" marT="0" marB="0" anchor="ctr">
-                    <a:lnL w="12700" cap="flat" cmpd="sng" algn="ctr">
-                      <a:solidFill>
-                        <a:srgbClr val="BBBBBB"/>
-                      </a:solidFill>
-                      <a:prstDash val="solid"/>
-                      <a:round/>
-                      <a:headEnd type="none" w="med" len="med"/>
-                      <a:tailEnd type="none" w="med" len="med"/>
-                    </a:lnL>
-                    <a:lnR w="12700" cap="flat" cmpd="sng" algn="ctr">
-                      <a:solidFill>
-                        <a:srgbClr val="BBBBBB"/>
-                      </a:solidFill>
-                      <a:prstDash val="solid"/>
-                      <a:round/>
-                      <a:headEnd type="none" w="med" len="med"/>
-                      <a:tailEnd type="none" w="med" len="med"/>
-                    </a:lnR>
-                    <a:lnT w="12700" cap="flat" cmpd="sng" algn="ctr">
-                      <a:solidFill>
-                        <a:srgbClr val="BBBBBB"/>
-                      </a:solidFill>
-                      <a:prstDash val="solid"/>
-                      <a:round/>
-                      <a:headEnd type="none" w="med" len="med"/>
-                      <a:tailEnd type="none" w="med" len="med"/>
-                    </a:lnT>
-                    <a:lnB w="12700" cap="flat" cmpd="sng" algn="ctr">
-                      <a:solidFill>
-                        <a:srgbClr val="BBBBBB"/>
-                      </a:solidFill>
-                      <a:prstDash val="solid"/>
-                      <a:round/>
-                      <a:headEnd type="none" w="med" len="med"/>
-                      <a:tailEnd type="none" w="med" len="med"/>
-                    </a:lnB>
-                    <a:solidFill>
-                      <a:srgbClr val="FFFFFF"/>
-                    </a:solidFill>
-                  </a:tcPr>
-                </a:tc>
-                <a:extLst>
-                  <a:ext uri="{0D108BD9-81ED-4DB2-BD59-A6C34878D82A}">
-                    <a16:rowId xmlns:a16="http://schemas.microsoft.com/office/drawing/2014/main" val="10003"/>
-                  </a:ext>
-                </a:extLst>
-              </a:tr>
-              <a:tr h="457200">
-                <a:tc>
-                  <a:txBody>
-                    <a:bodyPr/>
-                    <a:lstStyle/>
-                    <a:p>
-                      <a:pPr marL="0" indent="0">
-                        <a:buNone/>
-                      </a:pPr>
-                      <a:r>
-                        <a:rPr lang="en-US" sz="1400" b="1" dirty="0">
-                          <a:solidFill>
-                            <a:srgbClr val="000000"/>
-                          </a:solidFill>
-                          <a:latin typeface="Calibri" pitchFamily="34" charset="0"/>
-                          <a:ea typeface="Calibri" pitchFamily="34" charset="-122"/>
-                          <a:cs typeface="Calibri" pitchFamily="34" charset="-120"/>
-                        </a:rPr>
                         <a:t>Unique</a:t>
                       </a:r>
                       <a:endParaRPr lang="en-US" sz="1400" dirty="0">
@@ -4616,7 +4194,7 @@
                           <a:ea typeface="Calibri" pitchFamily="34" charset="-122"/>
                           <a:cs typeface="Calibri" pitchFamily="34" charset="-120"/>
                         </a:rPr>
-                        <a:t>65</a:t>
+                        <a:t>70</a:t>
                       </a:r>
                       <a:endParaRPr lang="en-US" sz="1400" dirty="0">
                         <a:latin typeface="Calibri" charset="0"/>
@@ -4753,8 +4331,8 @@
         </p:nvSpPr>
         <p:spPr>
           <a:xfrm>
-            <a:off x="6400800" y="5029200"/>
-            <a:ext cx="5212080" cy="1005840"/>
+            <a:off x="6400800" y="4114800"/>
+            <a:ext cx="5212080" cy="1828800"/>
           </a:xfrm>
           <a:prstGeom prst="rect">
             <a:avLst/>
@@ -4767,6 +4345,9 @@
           <a:lstStyle/>
           <a:p>
             <a:pPr marL="0" indent="0">
+              <a:spcAft>
+                <a:spcPts val="400"/>
+              </a:spcAft>
               <a:buNone/>
             </a:pPr>
             <a:r>
@@ -4778,8 +4359,47 @@
                 <a:ea typeface="Calibri" pitchFamily="34" charset="-122"/>
                 <a:cs typeface="Calibri" pitchFamily="34" charset="-120"/>
               </a:rPr>
-              <a:t>Per annotator, per batch: 20 + 10 + 5 + 65 = 100 items.
-Distinct conversations: 20 + 30 + 10 + 390 = 450 per round. Up to 900 across both rounds.</a:t>
+              <a:t>Per annotator, per batch: 30 + 70 = 100 items.</a:t>
+            </a:r>
+            <a:endParaRPr lang="en-US" sz="1500" dirty="0"/>
+          </a:p>
+          <a:p>
+            <a:pPr marL="0" indent="0">
+              <a:spcAft>
+                <a:spcPts val="400"/>
+              </a:spcAft>
+              <a:buNone/>
+            </a:pPr>
+            <a:r>
+              <a:rPr lang="en-US" sz="1500" dirty="0">
+                <a:solidFill>
+                  <a:schemeClr val="tx2"/>
+                </a:solidFill>
+                <a:latin typeface="Calibri" pitchFamily="34" charset="0"/>
+                <a:ea typeface="Calibri" pitchFamily="34" charset="-122"/>
+                <a:cs typeface="Calibri" pitchFamily="34" charset="-120"/>
+              </a:rPr>
+              <a:t>Distinct conversations: 30 + 420 = 450 per round. Up to 900 across both rounds.</a:t>
+            </a:r>
+            <a:endParaRPr lang="en-US" sz="1500" dirty="0"/>
+          </a:p>
+          <a:p>
+            <a:pPr marL="0" indent="0">
+              <a:spcAft>
+                <a:spcPts val="400"/>
+              </a:spcAft>
+              <a:buNone/>
+            </a:pPr>
+            <a:r>
+              <a:rPr lang="en-US" sz="1500" dirty="0">
+                <a:solidFill>
+                  <a:schemeClr val="tx2"/>
+                </a:solidFill>
+                <a:latin typeface="Calibri" pitchFamily="34" charset="0"/>
+                <a:ea typeface="Calibri" pitchFamily="34" charset="-122"/>
+                <a:cs typeface="Calibri" pitchFamily="34" charset="-120"/>
+              </a:rPr>
+              <a:t>Each shared item gets 6 labels, for agreement and a majority vote.</a:t>
             </a:r>
             <a:endParaRPr lang="en-US" sz="1500" dirty="0"/>
           </a:p>
@@ -5828,7 +5448,7 @@
                 <a:ea typeface="Calibri" pitchFamily="34" charset="-122"/>
                 <a:cs typeface="Calibri" pitchFamily="34" charset="-120"/>
               </a:rPr>
-              <a:t>2.8M support tweets, zero tone labels. “Thanks a lot” can be praise or sarcasm, so you need the whole conversation.</a:t>
+              <a:t>2.8M support tweets, zero tone labels. “Thanks a lot” can be praise or sarcasm, and sometimes only earlier messages tell you which.</a:t>
             </a:r>
             <a:endParaRPr lang="en-US" sz="1400" dirty="0"/>
           </a:p>
@@ -5980,7 +5600,7 @@
                 <a:ea typeface="Calibri" pitchFamily="34" charset="-122"/>
                 <a:cs typeface="Calibri" pitchFamily="34" charset="-120"/>
               </a:rPr>
-              <a:t>Classify the customer's overall tone across the complete conversation. Agent replies provide context; the last message alone may be misleading.</a:t>
+              <a:t>Label the tone of the customer’s last message. If it is unclear on its own, use the earlier conversation as context.</a:t>
             </a:r>
             <a:endParaRPr lang="en-US" sz="2000" dirty="0"/>
           </a:p>
@@ -6924,7 +6544,7 @@
                 <a:ea typeface="Calibri" pitchFamily="34" charset="-122"/>
                 <a:cs typeface="Calibri" pitchFamily="34" charset="-120"/>
               </a:rPr>
-              <a:t>When multiple tones apply across the exchange: Escalatory, Frustrated, Help-seeking, Appreciative, Neutral.</a:t>
+              <a:t>If the last message shows more than one tone: Escalatory, Frustrated, Help-seeking, Appreciative, Neutral.</a:t>
             </a:r>
             <a:endParaRPr lang="en-US" sz="1800" dirty="0"/>
           </a:p>
@@ -7466,7 +7086,7 @@
                 <a:ea typeface="Calibri" pitchFamily="34" charset="-122"/>
                 <a:cs typeface="Calibri" pitchFamily="34" charset="-120"/>
               </a:rPr>
-              <a:t>The customer expresses enthusiasm in both messages, praising the movie and saying “Awesome thanks”. The exchange supports an Appreciative label.</a:t>
+              <a:t>The last message, “Awesome thanks”, is genuine enthusiasm. The earlier praise for the movie confirms it is not sarcasm.</a:t>
             </a:r>
             <a:endParaRPr lang="en-US" sz="1600" dirty="0"/>
           </a:p>

</xml_diff>